<commit_message>
Lecture 5: upgrade Q4 from recall to a threshold DECIDE beat
Active-learning review: slide 29 / Quiz 5 Q4 changed from 'restate what box &
score mean' (recall of the slide-28 I-do) into a decide beat. New you-do figure
boxes two candidates with given scores (sharp peak 0.95, small shoulder 0.30);
students decide which to integrate, which survives a 0.5 vs 0.2 confidence
threshold, and name the trade-off (more recall vs more false peaks) tying back
to the Lecture 4/10 threshold dial. New peak_detection_decide() figure; deck
stays 32 slides. Rebuilt pptx force-added.
</commit_message>
<xml_diff>
--- a/slides/pptx/lecture05_cnns.pptx
+++ b/slides/pptx/lecture05_cnns.pptx
@@ -2024,7 +2024,7 @@
           <a:lstStyle/>
           <a:p>
             <a:r>
-              <a:t>YOU-DO = Quiz 5 Q4 (the same reframe, now stated by the room; it assesses the detection outcome). Answer: the BOX is the peak's retention-time (or m/z) window — the integration bounds marking where the peak starts and ends along the axis; the SCORE is the model's confidence, from 0 to 1, that the boxed region is a genuine peak rather than baseline noise or an artifact (i.e. how sure it is the object is really there / really a good peak). Any answer capturing "box = the RT/m/z integration window bounding the peak" and "score = confidence it's a real peak" earns full credit. Matches the Quiz 5 key. Take one answer from the floor, then have them fill Q4.</a:t>
+              <a:t>YOU-DO = Quiz 5 Q4 — a DECIDE beat, not "restate the mapping." The scores are the given data; each box = that peak's RT integration window (stated on the I-do slide before this). Answers: (a) integrate the 0.95 box — a confident, genuine peak; the 0.30 box is a low-confidence shoulder/noise the model is unsure is real, so flag-for-review or drop it. (b) threshold 0.5 keeps only the 0.95 peak (0.30 &lt; 0.5 is dropped) → 1 clean peak; threshold 0.2 keeps BOTH (0.30 ≥ 0.2) → the dubious bump gets integrated too. (c) lowering the threshold catches more real peaks (higher sensitivity/recall) but admits more false ones (lower specificity/ precision) — the exact threshold trade-off from Lectures 4 and 10, and the SCORE is the dial that lets you choose. Have a pair make the 0.5-vs-0.2 call before revealing, then fill Q4.</a:t>
             </a:r>
           </a:p>
           <a:p/>
@@ -11502,7 +11502,7 @@
         <p:spPr>
           <a:xfrm>
             <a:off x="548640" y="731520"/>
-            <a:ext cx="11064240" cy="1005840"/>
+            <a:ext cx="11064240" cy="1127760"/>
           </a:xfrm>
           <a:prstGeom prst="rect">
             <a:avLst/>
@@ -11522,7 +11522,7 @@
                 </a:solidFill>
                 <a:latin typeface="Avenir Next"/>
               </a:rPr>
-              <a:t>Name the box and the score</a:t>
+              <a:t>Read the detector's calls — which do you trust?</a:t>
             </a:r>
           </a:p>
         </p:txBody>
@@ -11560,7 +11560,7 @@
         <p:spPr>
           <a:xfrm>
             <a:off x="548640" y="5486400"/>
-            <a:ext cx="10515600" cy="923544"/>
+            <a:ext cx="10515600" cy="1182624"/>
           </a:xfrm>
           <a:prstGeom prst="rect">
             <a:avLst/>
@@ -11610,7 +11610,7 @@
                 </a:solidFill>
                 <a:latin typeface="Avenir Next"/>
               </a:rPr>
-              <a:t>Your turn → Quiz 5, Q4. For a CNN doing peak detection on a chromatogram: what does the bounding BOX correspond to, and what does the confidence SCORE mean? One line each. Worked answer in the notes.</a:t>
+              <a:t>Your turn → Quiz 5, Q4. The detector boxed two candidates: a sharp peak at score 0.95 and a small shoulder at 0.30. (a) Which do you integrate, and what does the 0.30 tell you? (b) Which peaks survive a 0.5 threshold? A 0.2 threshold? (c) What does lowering the threshold trade off? Worked answer in the notes.</a:t>
             </a:r>
           </a:p>
         </p:txBody>

</xml_diff>